<commit_message>
[SQ5GEN-195] feat: add user-chosen 16:9/4:3/3:2 PPT canvases
Lock aspect ratio before backend selection, assemble matching Medavis templates, and refuse mismatched images instead of stretching.
</commit_message>
<xml_diff>
--- a/skills/codex-ppt/assets/templates/medavis_ppt_template_2026_en_16-9.pptx
+++ b/skills/codex-ppt/assets/templates/medavis_ppt_template_2026_en_16-9.pptx
@@ -12,6 +12,7 @@
   </p:handoutMasterIdLst>
   <p:sldIdLst>
     <p:sldId id="269" r:id="rId2"/>
+    <p:sldId id="271" r:id="rId11"/>
     <p:sldId id="270" r:id="rId3"/>
   </p:sldIdLst>
   <p:sldSz cx="9144000" cy="5143500" type="screen16x9"/>
@@ -280,7 +281,7 @@
           <a:p>
             <a:fld id="{A0277FD4-9FBE-4907-8FBA-962548D89053}" type="datetimeFigureOut">
               <a:rPr lang="de-DE" smtClean="0"/>
-              <a:t>12.08.2026</a:t>
+              <a:t>13.08.2026</a:t>
             </a:fld>
             <a:endParaRPr lang="de-DE"/>
           </a:p>
@@ -484,7 +485,7 @@
               <a:pPr>
                 <a:defRPr/>
               </a:pPr>
-              <a:t>12.08.2026</a:t>
+              <a:t>13.08.2026</a:t>
             </a:fld>
             <a:endParaRPr lang="de-DE"/>
           </a:p>
@@ -1101,6 +1102,39 @@
 </p:sldLayout>
 </file>
 
+<file path=ppt/slideLayouts/slideLayout10.xml><?xml version="1.0" encoding="utf-8"?>
+<p:sldLayout xmlns:a="http://schemas.openxmlformats.org/drawingml/2006/main" xmlns:r="http://schemas.openxmlformats.org/officeDocument/2006/relationships" xmlns:p="http://schemas.openxmlformats.org/presentationml/2006/main" type="blank" showMasterSp="0" preserve="1">
+  <p:cSld name="Blank">
+    <p:bg>
+      <p:bgPr>
+        <a:solidFill>
+          <a:srgbClr val="FFFFFF"/>
+        </a:solidFill>
+        <a:effectLst/>
+      </p:bgPr>
+    </p:bg>
+    <p:spTree>
+      <p:nvGrpSpPr>
+        <p:cNvPr id="1" name=""/>
+        <p:cNvGrpSpPr/>
+        <p:nvPr/>
+      </p:nvGrpSpPr>
+      <p:grpSpPr>
+        <a:xfrm>
+          <a:off x="0" y="0"/>
+          <a:ext cx="0" cy="0"/>
+          <a:chOff x="0" y="0"/>
+          <a:chExt cx="0" cy="0"/>
+        </a:xfrm>
+      </p:grpSpPr>
+    </p:spTree>
+  </p:cSld>
+  <p:clrMapOvr>
+    <a:masterClrMapping/>
+  </p:clrMapOvr>
+</p:sldLayout>
+</file>
+
 <file path=ppt/slideLayouts/slideLayout2.xml><?xml version="1.0" encoding="utf-8"?>
 <p:sldLayout xmlns:a="http://schemas.openxmlformats.org/drawingml/2006/main" xmlns:r="http://schemas.openxmlformats.org/officeDocument/2006/relationships" xmlns:p="http://schemas.openxmlformats.org/presentationml/2006/main" showMasterSp="0" preserve="1" userDrawn="1">
   <p:cSld name="3_Titelfolie">
@@ -4124,6 +4158,7 @@
     <p:sldLayoutId id="2147483734" r:id="rId7"/>
     <p:sldLayoutId id="2147483735" r:id="rId8"/>
     <p:sldLayoutId id="2147483736" r:id="rId9"/>
+    <p:sldLayoutId id="2147483740" r:id="rId12"/>
   </p:sldLayoutIdLst>
   <p:transition spd="slow" advClick="0" advTm="4000"/>
   <p:hf hdr="0" ftr="0" dt="0"/>
@@ -4526,6 +4561,39 @@
           <a:chExt cx="0" cy="0"/>
         </a:xfrm>
       </p:grpSpPr>
+      <p:sp>
+        <p:nvSpPr>
+          <p:cNvPr id="2" name="Inhaltsplatzhalter 3">
+            <a:extLst>
+              <a:ext uri="{FF2B5EF4-FFF2-40B4-BE49-F238E27FC236}">
+                <a16:creationId xmlns:a16="http://schemas.microsoft.com/office/drawing/2014/main" id="{747F1673-9835-6371-2A9F-4BF6092FDE8C}"/>
+              </a:ext>
+            </a:extLst>
+          </p:cNvPr>
+          <p:cNvSpPr>
+            <a:spLocks noGrp="1"/>
+          </p:cNvSpPr>
+          <p:nvPr>
+            <p:ph idx="1"/>
+          </p:nvPr>
+        </p:nvSpPr>
+        <p:spPr>
+          <a:xfrm>
+            <a:off x="990600" y="2952750"/>
+            <a:ext cx="7315200" cy="609600"/>
+          </a:xfrm>
+        </p:spPr>
+        <p:txBody>
+          <a:bodyPr/>
+          <a:lstStyle/>
+          <a:p>
+            <a:r>
+              <a:rPr lang="en-US" sz="2800" b="1" dirty="0"/>
+              <a:t>&lt;PPT-Title&gt;</a:t>
+            </a:r>
+          </a:p>
+        </p:txBody>
+      </p:sp>
     </p:spTree>
     <p:extLst>
       <p:ext uri="{BB962C8B-B14F-4D97-AF65-F5344CB8AC3E}">
@@ -4541,6 +4609,31 @@
 </file>
 
 <file path=ppt/slides/slide2.xml><?xml version="1.0" encoding="utf-8"?>
+<p:sld xmlns:a="http://schemas.openxmlformats.org/drawingml/2006/main" xmlns:r="http://schemas.openxmlformats.org/officeDocument/2006/relationships" xmlns:p="http://schemas.openxmlformats.org/presentationml/2006/main" showMasterSp="0">
+  <p:cSld>
+    <p:spTree>
+      <p:nvGrpSpPr>
+        <p:cNvPr id="1" name=""/>
+        <p:cNvGrpSpPr/>
+        <p:nvPr/>
+      </p:nvGrpSpPr>
+      <p:grpSpPr>
+        <a:xfrm>
+          <a:off x="0" y="0"/>
+          <a:ext cx="0" cy="0"/>
+          <a:chOff x="0" y="0"/>
+          <a:chExt cx="0" cy="0"/>
+        </a:xfrm>
+      </p:grpSpPr>
+    </p:spTree>
+  </p:cSld>
+  <p:clrMapOvr>
+    <a:masterClrMapping/>
+  </p:clrMapOvr>
+</p:sld>
+</file>
+
+<file path=ppt/slides/slide3.xml><?xml version="1.0" encoding="utf-8"?>
 <p:sld xmlns:a="http://schemas.openxmlformats.org/drawingml/2006/main" xmlns:r="http://schemas.openxmlformats.org/officeDocument/2006/relationships" xmlns:p="http://schemas.openxmlformats.org/presentationml/2006/main">
   <p:cSld>
     <p:spTree>
@@ -4557,6 +4650,203 @@
           <a:chExt cx="0" cy="0"/>
         </a:xfrm>
       </p:grpSpPr>
+      <p:pic>
+        <p:nvPicPr>
+          <p:cNvPr id="3" name="Picture 2">
+            <a:extLst>
+              <a:ext uri="{FF2B5EF4-FFF2-40B4-BE49-F238E27FC236}">
+                <a16:creationId xmlns:a16="http://schemas.microsoft.com/office/drawing/2014/main" id="{4C3DEAA2-70C6-6ABF-CE8A-48A597210880}"/>
+              </a:ext>
+            </a:extLst>
+          </p:cNvPr>
+          <p:cNvPicPr>
+            <a:picLocks noChangeAspect="1"/>
+          </p:cNvPicPr>
+          <p:nvPr/>
+        </p:nvPicPr>
+        <p:blipFill>
+          <a:blip r:embed="rId2">
+            <a:extLst>
+              <a:ext uri="{28A0092B-C50C-407E-A947-70E740481C1C}">
+                <a14:useLocalDpi xmlns:a14="http://schemas.microsoft.com/office/drawing/2010/main" val="0"/>
+              </a:ext>
+            </a:extLst>
+          </a:blip>
+          <a:stretch>
+            <a:fillRect/>
+          </a:stretch>
+        </p:blipFill>
+        <p:spPr>
+          <a:xfrm>
+            <a:off x="0" y="0"/>
+            <a:ext cx="9144000" cy="5143500"/>
+          </a:xfrm>
+          <a:prstGeom prst="rect">
+            <a:avLst/>
+          </a:prstGeom>
+        </p:spPr>
+      </p:pic>
+      <p:sp>
+        <p:nvSpPr>
+          <p:cNvPr id="11" name="Rounded Rectangle 10"/>
+          <p:cNvSpPr/>
+          <p:nvPr/>
+        </p:nvSpPr>
+        <p:spPr>
+          <a:xfrm>
+            <a:off x="987552" y="1033272"/>
+            <a:ext cx="7168896" cy="1444752"/>
+          </a:xfrm>
+          <a:prstGeom prst="roundRect">
+            <a:avLst/>
+          </a:prstGeom>
+          <a:solidFill>
+            <a:srgbClr val="FFFFFF">
+              <a:alpha val="72000"/>
+            </a:srgbClr>
+          </a:solidFill>
+          <a:ln>
+            <a:noFill/>
+          </a:ln>
+        </p:spPr>
+        <p:style>
+          <a:lnRef idx="1">
+            <a:schemeClr val="accent1"/>
+          </a:lnRef>
+          <a:fillRef idx="3">
+            <a:schemeClr val="accent1"/>
+          </a:fillRef>
+          <a:effectRef idx="2">
+            <a:schemeClr val="accent1"/>
+          </a:effectRef>
+          <a:fontRef idx="minor">
+            <a:schemeClr val="lt1"/>
+          </a:fontRef>
+        </p:style>
+        <p:txBody>
+          <a:bodyPr rtlCol="0" anchor="ctr"/>
+          <a:lstStyle/>
+          <a:p>
+            <a:pPr algn="ctr"/>
+          </a:p>
+        </p:txBody>
+      </p:sp>
+      <p:sp>
+        <p:nvSpPr>
+          <p:cNvPr id="7" name="TextBox 6">
+            <a:extLst>
+              <a:ext uri="{FF2B5EF4-FFF2-40B4-BE49-F238E27FC236}">
+                <a16:creationId xmlns:a16="http://schemas.microsoft.com/office/drawing/2014/main" id="{1F011FF0-8E2C-380C-164F-F738AFFA8884}"/>
+              </a:ext>
+            </a:extLst>
+          </p:cNvPr>
+          <p:cNvSpPr txBox="1"/>
+          <p:nvPr/>
+        </p:nvSpPr>
+        <p:spPr>
+          <a:xfrm>
+            <a:off x="1188720" y="1234440"/>
+            <a:ext cx="6766560" cy="502920"/>
+          </a:xfrm>
+          <a:prstGeom prst="rect">
+            <a:avLst/>
+          </a:prstGeom>
+          <a:noFill/>
+        </p:spPr>
+        <p:txBody>
+          <a:bodyPr wrap="square" rtlCol="0">
+            <a:noAutofit/>
+          </a:bodyPr>
+          <a:lstStyle/>
+          <a:p>
+            <a:pPr algn="ctr"/>
+            <a:r>
+              <a:rPr lang="en-US" altLang="zh-CN" dirty="0" sz="2800" b="1">
+                <a:solidFill>
+                  <a:schemeClr val="accent6"/>
+                </a:solidFill>
+                <a:latin typeface="Verdana"/>
+              </a:rPr>
+              <a:t>Thank You For Your Patience</a:t>
+            </a:r>
+            <a:endParaRPr lang="zh-CN" altLang="en-US" dirty="0">
+              <a:solidFill>
+                <a:schemeClr val="accent6"/>
+              </a:solidFill>
+            </a:endParaRPr>
+          </a:p>
+        </p:txBody>
+      </p:sp>
+      <p:sp>
+        <p:nvSpPr>
+          <p:cNvPr id="9" name="TextBox 8">
+            <a:extLst>
+              <a:ext uri="{FF2B5EF4-FFF2-40B4-BE49-F238E27FC236}">
+                <a16:creationId xmlns:a16="http://schemas.microsoft.com/office/drawing/2014/main" id="{DC7FF02F-4D94-5484-048D-67727ABAA7E9}"/>
+              </a:ext>
+            </a:extLst>
+          </p:cNvPr>
+          <p:cNvSpPr txBox="1"/>
+          <p:nvPr/>
+        </p:nvSpPr>
+        <p:spPr>
+          <a:xfrm>
+            <a:off x="1188720" y="1773936"/>
+            <a:ext cx="6766560" cy="502920"/>
+          </a:xfrm>
+          <a:prstGeom prst="rect">
+            <a:avLst/>
+          </a:prstGeom>
+          <a:noFill/>
+        </p:spPr>
+        <p:txBody>
+          <a:bodyPr wrap="square" rtlCol="0">
+            <a:noAutofit/>
+          </a:bodyPr>
+          <a:lstStyle/>
+          <a:p>
+            <a:pPr algn="ctr"/>
+            <a:r>
+              <a:rPr lang="de-DE" altLang="zh-CN" dirty="0" sz="2200" b="1">
+                <a:solidFill>
+                  <a:schemeClr val="accent2"/>
+                </a:solidFill>
+                <a:latin typeface="Verdana"/>
+              </a:rPr>
+              <a:t>Vielen Dank für Ihre Geduld</a:t>
+            </a:r>
+            <a:endParaRPr lang="zh-CN" altLang="en-US" dirty="0">
+              <a:solidFill>
+                <a:schemeClr val="accent2"/>
+              </a:solidFill>
+            </a:endParaRPr>
+          </a:p>
+        </p:txBody>
+      </p:sp>
+      <p:pic>
+        <p:nvPicPr>
+          <p:cNvPr id="10" name="Picture 9" descr="image.png"/>
+          <p:cNvPicPr>
+            <a:picLocks noChangeAspect="1"/>
+          </p:cNvPicPr>
+          <p:nvPr/>
+        </p:nvPicPr>
+        <p:blipFill>
+          <a:blip r:embed="rId4"/>
+          <a:stretch>
+            <a:fillRect/>
+          </a:stretch>
+        </p:blipFill>
+        <p:spPr>
+          <a:xfrm>
+            <a:off x="6992667" y="256032"/>
+            <a:ext cx="1895301" cy="384048"/>
+          </a:xfrm>
+          <a:prstGeom prst="rect">
+            <a:avLst/>
+          </a:prstGeom>
+        </p:spPr>
+      </p:pic>
     </p:spTree>
     <p:extLst>
       <p:ext uri="{BB962C8B-B14F-4D97-AF65-F5344CB8AC3E}">

</xml_diff>